<commit_message>
V4.5 - Render stability fix (skip PDF + UI toggle)
</commit_message>
<xml_diff>
--- a/output/pitch_deck_v1.pptx
+++ b/output/pitch_deck_v1.pptx
@@ -3101,7 +3101,7 @@
       <p:grpSpPr/>
       <p:pic>
         <p:nvPicPr>
-          <p:cNvPr id="2" name="Picture 1" descr="tmps437ij07.jpg"/>
+          <p:cNvPr id="2" name="Picture 1" descr="tmp3gxifnz5.jpg"/>
           <p:cNvPicPr>
             <a:picLocks noChangeAspect="1"/>
           </p:cNvPicPr>
@@ -3125,7 +3125,7 @@
       </p:pic>
       <p:pic>
         <p:nvPicPr>
-          <p:cNvPr id="3" name="Picture 2" descr="tmpayynkxom.jpg"/>
+          <p:cNvPr id="3" name="Picture 2" descr="tmp9xdsfgrv.jpg"/>
           <p:cNvPicPr>
             <a:picLocks noChangeAspect="1"/>
           </p:cNvPicPr>
@@ -3219,7 +3219,7 @@
                   <a:srgbClr val="FFFFFF"/>
                 </a:solidFill>
               </a:rPr>
-              <a:t>I have no words to say right now!!</a:t>
+              <a:t>My logline!!!!</a:t>
             </a:r>
           </a:p>
         </p:txBody>
@@ -3244,7 +3244,7 @@
       <p:grpSpPr/>
       <p:pic>
         <p:nvPicPr>
-          <p:cNvPr id="2" name="Picture 1" descr="tmps437ij07.jpg"/>
+          <p:cNvPr id="2" name="Picture 1" descr="tmp3gxifnz5.jpg"/>
           <p:cNvPicPr>
             <a:picLocks noChangeAspect="1"/>
           </p:cNvPicPr>
@@ -3268,7 +3268,7 @@
       </p:pic>
       <p:pic>
         <p:nvPicPr>
-          <p:cNvPr id="3" name="Picture 2" descr="tmp14jjnq6f.jpg"/>
+          <p:cNvPr id="3" name="Picture 2" descr="tmpg_3378xx.jpg"/>
           <p:cNvPicPr>
             <a:picLocks noChangeAspect="1"/>
           </p:cNvPicPr>
@@ -3396,7 +3396,7 @@
                   <a:srgbClr val="FFFFFF"/>
                 </a:solidFill>
               </a:rPr>
-              <a:t>Elias stumbles into a role far bigger than expected, and each attempt to survive the absurd rules of the kingdom only pulls the chaos closer.</a:t>
+              <a:t>Harry is forced to balance a hidden life of danger with the illusion of normalcy, until escalating threats pull both worlds into collision.</a:t>
             </a:r>
           </a:p>
         </p:txBody>
@@ -3421,7 +3421,7 @@
       <p:grpSpPr/>
       <p:pic>
         <p:nvPicPr>
-          <p:cNvPr id="2" name="Picture 1" descr="tmps437ij07.jpg"/>
+          <p:cNvPr id="2" name="Picture 1" descr="tmp3gxifnz5.jpg"/>
           <p:cNvPicPr>
             <a:picLocks noChangeAspect="1"/>
           </p:cNvPicPr>
@@ -3445,7 +3445,7 @@
       </p:pic>
       <p:pic>
         <p:nvPicPr>
-          <p:cNvPr id="3" name="Picture 2" descr="tmp81hbycq0.jpg"/>
+          <p:cNvPr id="3" name="Picture 2" descr="tmpeqzftipy.jpg"/>
           <p:cNvPicPr>
             <a:picLocks noChangeAspect="1"/>
           </p:cNvPicPr>
@@ -3573,7 +3573,7 @@
                   <a:srgbClr val="FFFFFF"/>
                 </a:solidFill>
               </a:rPr>
-              <a:t>The truth behind the situation is different from what the protagonist first assumes.</a:t>
+              <a:t>The hidden life meant to protect the protagonist's family becomes the very thing that puts them in danger.</a:t>
             </a:r>
           </a:p>
         </p:txBody>
@@ -3598,7 +3598,7 @@
       <p:grpSpPr/>
       <p:pic>
         <p:nvPicPr>
-          <p:cNvPr id="2" name="Picture 1" descr="tmps437ij07.jpg"/>
+          <p:cNvPr id="2" name="Picture 1" descr="tmp3gxifnz5.jpg"/>
           <p:cNvPicPr>
             <a:picLocks noChangeAspect="1"/>
           </p:cNvPicPr>
@@ -3622,7 +3622,7 @@
       </p:pic>
       <p:pic>
         <p:nvPicPr>
-          <p:cNvPr id="3" name="Picture 2" descr="tmp14jjnq6f.jpg"/>
+          <p:cNvPr id="3" name="Picture 2" descr="tmpg_3378xx.jpg"/>
           <p:cNvPicPr>
             <a:picLocks noChangeAspect="1"/>
           </p:cNvPicPr>
@@ -3750,7 +3750,7 @@
                   <a:srgbClr val="FFFFFF"/>
                 </a:solidFill>
               </a:rPr>
-              <a:t>Elias stumbles into a role far bigger than expected, and each attempt to survive the absurd rules of the kingdom only pulls the chaos closer.</a:t>
+              <a:t>Harry is forced to balance a hidden life of danger with the illusion of normalcy, until escalating threats pull both worlds into collision.</a:t>
             </a:r>
           </a:p>
         </p:txBody>
@@ -3775,7 +3775,7 @@
       <p:grpSpPr/>
       <p:pic>
         <p:nvPicPr>
-          <p:cNvPr id="2" name="Picture 1" descr="tmps437ij07.jpg"/>
+          <p:cNvPr id="2" name="Picture 1" descr="tmp3gxifnz5.jpg"/>
           <p:cNvPicPr>
             <a:picLocks noChangeAspect="1"/>
           </p:cNvPicPr>
@@ -3799,7 +3799,7 @@
       </p:pic>
       <p:pic>
         <p:nvPicPr>
-          <p:cNvPr id="3" name="Picture 2" descr="tmp14jjnq6f.jpg"/>
+          <p:cNvPr id="3" name="Picture 2" descr="tmpg_3378xx.jpg"/>
           <p:cNvPicPr>
             <a:picLocks noChangeAspect="1"/>
           </p:cNvPicPr>
@@ -3927,7 +3927,7 @@
                   <a:srgbClr val="FFFFFF"/>
                 </a:solidFill>
               </a:rPr>
-              <a:t>I have no words to say right now!!</a:t>
+              <a:t>My logline!!!!</a:t>
             </a:r>
           </a:p>
         </p:txBody>
@@ -3952,7 +3952,7 @@
       <p:grpSpPr/>
       <p:pic>
         <p:nvPicPr>
-          <p:cNvPr id="2" name="Picture 1" descr="tmps437ij07.jpg"/>
+          <p:cNvPr id="2" name="Picture 1" descr="tmp3gxifnz5.jpg"/>
           <p:cNvPicPr>
             <a:picLocks noChangeAspect="1"/>
           </p:cNvPicPr>
@@ -3976,7 +3976,7 @@
       </p:pic>
       <p:pic>
         <p:nvPicPr>
-          <p:cNvPr id="3" name="Picture 2" descr="tmp81hbycq0.jpg"/>
+          <p:cNvPr id="3" name="Picture 2" descr="tmpeqzftipy.jpg"/>
           <p:cNvPicPr>
             <a:picLocks noChangeAspect="1"/>
           </p:cNvPicPr>
@@ -4104,7 +4104,7 @@
                   <a:srgbClr val="FFFFFF"/>
                 </a:solidFill>
               </a:rPr>
-              <a:t>Final Render ready test</a:t>
+              <a:t>Synopsis Here.</a:t>
             </a:r>
           </a:p>
         </p:txBody>
@@ -4129,7 +4129,7 @@
       <p:grpSpPr/>
       <p:pic>
         <p:nvPicPr>
-          <p:cNvPr id="2" name="Picture 1" descr="tmps437ij07.jpg"/>
+          <p:cNvPr id="2" name="Picture 1" descr="tmp3gxifnz5.jpg"/>
           <p:cNvPicPr>
             <a:picLocks noChangeAspect="1"/>
           </p:cNvPicPr>
@@ -4153,7 +4153,7 @@
       </p:pic>
       <p:pic>
         <p:nvPicPr>
-          <p:cNvPr id="3" name="Picture 2" descr="tmp14jjnq6f.jpg"/>
+          <p:cNvPr id="3" name="Picture 2" descr="tmpg_3378xx.jpg"/>
           <p:cNvPicPr>
             <a:picLocks noChangeAspect="1"/>
           </p:cNvPicPr>
@@ -4281,7 +4281,7 @@
                   <a:srgbClr val="FFFFFF"/>
                 </a:solidFill>
               </a:rPr>
-              <a:t>ELIAS</a:t>
+              <a:t>HARRY</a:t>
             </a:r>
           </a:p>
         </p:txBody>
@@ -4306,7 +4306,7 @@
       <p:grpSpPr/>
       <p:pic>
         <p:nvPicPr>
-          <p:cNvPr id="2" name="Picture 1" descr="tmps437ij07.jpg"/>
+          <p:cNvPr id="2" name="Picture 1" descr="tmp3gxifnz5.jpg"/>
           <p:cNvPicPr>
             <a:picLocks noChangeAspect="1"/>
           </p:cNvPicPr>
@@ -4330,7 +4330,7 @@
       </p:pic>
       <p:pic>
         <p:nvPicPr>
-          <p:cNvPr id="3" name="Picture 2" descr="tmp81hbycq0.jpg"/>
+          <p:cNvPr id="3" name="Picture 2" descr="tmpeqzftipy.jpg"/>
           <p:cNvPicPr>
             <a:picLocks noChangeAspect="1"/>
           </p:cNvPicPr>
@@ -4458,7 +4458,7 @@
                   <a:srgbClr val="FFFFFF"/>
                 </a:solidFill>
               </a:rPr>
-              <a:t>feature / fantasy satire comedy</a:t>
+              <a:t>feature / action espionage thriller</a:t>
             </a:r>
           </a:p>
         </p:txBody>
@@ -4483,7 +4483,7 @@
       <p:grpSpPr/>
       <p:pic>
         <p:nvPicPr>
-          <p:cNvPr id="2" name="Picture 1" descr="tmps437ij07.jpg"/>
+          <p:cNvPr id="2" name="Picture 1" descr="tmp3gxifnz5.jpg"/>
           <p:cNvPicPr>
             <a:picLocks noChangeAspect="1"/>
           </p:cNvPicPr>
@@ -4507,7 +4507,7 @@
       </p:pic>
       <p:pic>
         <p:nvPicPr>
-          <p:cNvPr id="3" name="Picture 2" descr="tmp14jjnq6f.jpg"/>
+          <p:cNvPr id="3" name="Picture 2" descr="tmpg_3378xx.jpg"/>
           <p:cNvPicPr>
             <a:picLocks noChangeAspect="1"/>
           </p:cNvPicPr>
@@ -4635,7 +4635,7 @@
                   <a:srgbClr val="FFFFFF"/>
                 </a:solidFill>
               </a:rPr>
-              <a:t>I have no words to say right now!!</a:t>
+              <a:t>My logline!!!!</a:t>
             </a:r>
           </a:p>
         </p:txBody>
@@ -4660,7 +4660,7 @@
       <p:grpSpPr/>
       <p:pic>
         <p:nvPicPr>
-          <p:cNvPr id="2" name="Picture 1" descr="tmps437ij07.jpg"/>
+          <p:cNvPr id="2" name="Picture 1" descr="tmp3gxifnz5.jpg"/>
           <p:cNvPicPr>
             <a:picLocks noChangeAspect="1"/>
           </p:cNvPicPr>
@@ -4684,7 +4684,7 @@
       </p:pic>
       <p:pic>
         <p:nvPicPr>
-          <p:cNvPr id="3" name="Picture 2" descr="tmp81hbycq0.jpg"/>
+          <p:cNvPr id="3" name="Picture 2" descr="tmpeqzftipy.jpg"/>
           <p:cNvPicPr>
             <a:picLocks noChangeAspect="1"/>
           </p:cNvPicPr>
@@ -4812,7 +4812,7 @@
                   <a:srgbClr val="FFFFFF"/>
                 </a:solidFill>
               </a:rPr>
-              <a:t>Elias must navigate ridiculous power structures, inflated egos, and escalating chaos without losing the part of themselves that makes them dangerous.</a:t>
+              <a:t>Harry must protect family, identity, and mission at once as secrets and escalating danger threaten to expose everything.</a:t>
             </a:r>
           </a:p>
         </p:txBody>
@@ -4837,7 +4837,7 @@
       <p:grpSpPr/>
       <p:pic>
         <p:nvPicPr>
-          <p:cNvPr id="2" name="Picture 1" descr="tmps437ij07.jpg"/>
+          <p:cNvPr id="2" name="Picture 1" descr="tmp3gxifnz5.jpg"/>
           <p:cNvPicPr>
             <a:picLocks noChangeAspect="1"/>
           </p:cNvPicPr>
@@ -4861,7 +4861,7 @@
       </p:pic>
       <p:pic>
         <p:nvPicPr>
-          <p:cNvPr id="3" name="Picture 2" descr="tmp14jjnq6f.jpg"/>
+          <p:cNvPr id="3" name="Picture 2" descr="tmpg_3378xx.jpg"/>
           <p:cNvPicPr>
             <a:picLocks noChangeAspect="1"/>
           </p:cNvPicPr>
@@ -4989,7 +4989,7 @@
                   <a:srgbClr val="FFFFFF"/>
                 </a:solidFill>
               </a:rPr>
-              <a:t>Elias must navigate ridiculous power structures, inflated egos, and escalating chaos without losing the part of themselves that makes them dangerous.</a:t>
+              <a:t>Harry must protect family, identity, and mission at once as secrets and escalating danger threaten to expose everything.</a:t>
             </a:r>
           </a:p>
         </p:txBody>
@@ -5014,7 +5014,7 @@
       <p:grpSpPr/>
       <p:pic>
         <p:nvPicPr>
-          <p:cNvPr id="2" name="Picture 1" descr="tmps437ij07.jpg"/>
+          <p:cNvPr id="2" name="Picture 1" descr="tmp3gxifnz5.jpg"/>
           <p:cNvPicPr>
             <a:picLocks noChangeAspect="1"/>
           </p:cNvPicPr>
@@ -5038,7 +5038,7 @@
       </p:pic>
       <p:pic>
         <p:nvPicPr>
-          <p:cNvPr id="3" name="Picture 2" descr="tmp81hbycq0.jpg"/>
+          <p:cNvPr id="3" name="Picture 2" descr="tmpeqzftipy.jpg"/>
           <p:cNvPicPr>
             <a:picLocks noChangeAspect="1"/>
           </p:cNvPicPr>
@@ -5166,7 +5166,7 @@
                   <a:srgbClr val="FFFFFF"/>
                 </a:solidFill>
               </a:rPr>
-              <a:t>playful, witty, satirical, adventurous</a:t>
+              <a:t>propulsive, high-stakes, witty, cinematic</a:t>
             </a:r>
           </a:p>
         </p:txBody>

</xml_diff>